<commit_message>
Update BI Info and Reports
</commit_message>
<xml_diff>
--- a/Event Registry/Event Registry Data.pptx
+++ b/Event Registry/Event Registry Data.pptx
@@ -270,7 +270,7 @@
           <a:p>
             <a:fld id="{37A2730A-859E-B540-ADF3-E97069AD1FDB}" type="datetimeFigureOut">
               <a:rPr lang="en-US" smtClean="0"/>
-              <a:t>1/18/2025</a:t>
+              <a:t>1/19/2025</a:t>
             </a:fld>
             <a:endParaRPr lang="en-US"/>
           </a:p>
@@ -468,7 +468,7 @@
           <a:p>
             <a:fld id="{37A2730A-859E-B540-ADF3-E97069AD1FDB}" type="datetimeFigureOut">
               <a:rPr lang="en-US" smtClean="0"/>
-              <a:t>1/18/2025</a:t>
+              <a:t>1/19/2025</a:t>
             </a:fld>
             <a:endParaRPr lang="en-US"/>
           </a:p>
@@ -676,7 +676,7 @@
           <a:p>
             <a:fld id="{37A2730A-859E-B540-ADF3-E97069AD1FDB}" type="datetimeFigureOut">
               <a:rPr lang="en-US" smtClean="0"/>
-              <a:t>1/18/2025</a:t>
+              <a:t>1/19/2025</a:t>
             </a:fld>
             <a:endParaRPr lang="en-US"/>
           </a:p>
@@ -874,7 +874,7 @@
           <a:p>
             <a:fld id="{37A2730A-859E-B540-ADF3-E97069AD1FDB}" type="datetimeFigureOut">
               <a:rPr lang="en-US" smtClean="0"/>
-              <a:t>1/18/2025</a:t>
+              <a:t>1/19/2025</a:t>
             </a:fld>
             <a:endParaRPr lang="en-US"/>
           </a:p>
@@ -1149,7 +1149,7 @@
           <a:p>
             <a:fld id="{37A2730A-859E-B540-ADF3-E97069AD1FDB}" type="datetimeFigureOut">
               <a:rPr lang="en-US" smtClean="0"/>
-              <a:t>1/18/2025</a:t>
+              <a:t>1/19/2025</a:t>
             </a:fld>
             <a:endParaRPr lang="en-US"/>
           </a:p>
@@ -1414,7 +1414,7 @@
           <a:p>
             <a:fld id="{37A2730A-859E-B540-ADF3-E97069AD1FDB}" type="datetimeFigureOut">
               <a:rPr lang="en-US" smtClean="0"/>
-              <a:t>1/18/2025</a:t>
+              <a:t>1/19/2025</a:t>
             </a:fld>
             <a:endParaRPr lang="en-US"/>
           </a:p>
@@ -1826,7 +1826,7 @@
           <a:p>
             <a:fld id="{37A2730A-859E-B540-ADF3-E97069AD1FDB}" type="datetimeFigureOut">
               <a:rPr lang="en-US" smtClean="0"/>
-              <a:t>1/18/2025</a:t>
+              <a:t>1/19/2025</a:t>
             </a:fld>
             <a:endParaRPr lang="en-US"/>
           </a:p>
@@ -1967,7 +1967,7 @@
           <a:p>
             <a:fld id="{37A2730A-859E-B540-ADF3-E97069AD1FDB}" type="datetimeFigureOut">
               <a:rPr lang="en-US" smtClean="0"/>
-              <a:t>1/18/2025</a:t>
+              <a:t>1/19/2025</a:t>
             </a:fld>
             <a:endParaRPr lang="en-US"/>
           </a:p>
@@ -2080,7 +2080,7 @@
           <a:p>
             <a:fld id="{37A2730A-859E-B540-ADF3-E97069AD1FDB}" type="datetimeFigureOut">
               <a:rPr lang="en-US" smtClean="0"/>
-              <a:t>1/18/2025</a:t>
+              <a:t>1/19/2025</a:t>
             </a:fld>
             <a:endParaRPr lang="en-US"/>
           </a:p>
@@ -2391,7 +2391,7 @@
           <a:p>
             <a:fld id="{37A2730A-859E-B540-ADF3-E97069AD1FDB}" type="datetimeFigureOut">
               <a:rPr lang="en-US" smtClean="0"/>
-              <a:t>1/18/2025</a:t>
+              <a:t>1/19/2025</a:t>
             </a:fld>
             <a:endParaRPr lang="en-US"/>
           </a:p>
@@ -2679,7 +2679,7 @@
           <a:p>
             <a:fld id="{37A2730A-859E-B540-ADF3-E97069AD1FDB}" type="datetimeFigureOut">
               <a:rPr lang="en-US" smtClean="0"/>
-              <a:t>1/18/2025</a:t>
+              <a:t>1/19/2025</a:t>
             </a:fld>
             <a:endParaRPr lang="en-US"/>
           </a:p>
@@ -2920,7 +2920,7 @@
           <a:p>
             <a:fld id="{37A2730A-859E-B540-ADF3-E97069AD1FDB}" type="datetimeFigureOut">
               <a:rPr lang="en-US" smtClean="0"/>
-              <a:t>1/18/2025</a:t>
+              <a:t>1/19/2025</a:t>
             </a:fld>
             <a:endParaRPr lang="en-US"/>
           </a:p>
@@ -3742,21 +3742,21 @@
     <we:property name="Microsoft.Office.CampaignId" value="&quot;none&quot;"/>
     <we:property name="artifactViewState" value="&quot;live&quot;"/>
     <we:property name="backgroundColor" value="&quot;#345574&quot;"/>
-    <we:property name="bookmark" value="&quot;H4sIAAAAAAAAA+1abW/bNhD+K4aAoV+cgNSrlW9r0gLDki5rugxFEQQn8uSokCWPotJ4gf/7jpTc2Yod21mcpGsDf5D4cvfwuTvyeMqtI7NqnMPkHYzQOXBOQAmQpepxp+8UTVsYQBT6ocul8D0QbsQHLvWWY52VReUc3Doa1BD1eVbVkBtB1PjJETwZSCHT2PNCkYQQRZ7nXPQdyPNTGJoxKeQV9p0xqqosIM/+xkYEdWlV47Tv4M04LxUYRWcaNBpl1zSc3gkY3/cIBwidXeMZCt22JhJlwmLBBoEXenwQxyENq5oBFu/SIdSeZrkm6eYxmby5GStax+2MBj8lGtyBB65knuBEhIxIrp6MTe8hoRuWKhOQOxa3wqqBeesclnk9sk9vFtrPyloJfI+p7Sp0pickSWajS5KChQTlTImEU1USRbbvI4LaOykLfWV7rsovhwpJs3QO+PSCWq4tgYc0ArKiXYqElA0EEyxBHwYMBMS4erXtej6U43c7XMiRMebdJfS7+huMRuz5zOxu33mrypEF23ptVSd/1agmNKEDbNZBz7/PHu6TJI3fL66grAutJpcKh2ZS3/lgATKDtZ00mp9zglDVCucGks+fYU7uZxVtxGHz0uDpMNficai1VZ9mmEvHqPlNSVSvJ1bPUaZmIeF2aZlh3BDEqIvhLWgKV51REE+nRjFZi8zHpmZcs2x3jp8tSCVZf16hgWapKmSmW2i/dDirHpdNuwpIclw9+6uXTc3fxfQRomORhpXYFsOEzYXJs28782B+ltdQCGrtItnM3+6EUAfFYT2qczCbfe+sHvUMqN4qUMY6VVYM8/ZIsQeHfWo8zQEae3gFSpuTLPlMoWI2QppVLo8h3o2hHbFr/LA50WjE57kzq7X0ZHO33175hQ1gnqbgchYmPEwinwmX88Ha8+JpHHHpsfGELriw8b0AFL3jj88J5KdzUPu9OTjXKxB9S+HY+thTB2KrtglBzwVfxn6cJDH4AQu4yZ3XheCOjf1Hrvd7hBIeYl8BSj7UtI8P37BMJPmpCzJKEi59xtwojPn6vPiR97kHJgBr+a7yTFDePM+4M0K6pTUXAmLBrGnc6DLbmekvpe1Gu+Rb5zgjGhrZ55DXRuyrI5ohyy/Fq1kSNF0RJXbGFjnag2hpggXTZBAkHOMQgySIfBSCvSg7zrX+MONdVhorBoL5saTLOKf7NePM9WTwhFZMafmXWSEUjpAuz3kXLV5T86VV+13ZcSte2jsRFNWsYNOoVGXe1IRaGHS05jQxb3rtpYr02hFdfftzCmhaVhH8HMaVId4UiUzTaVYUs3dzbKuy1GYRmUS7jNniizrPW5ICSIEHA8ZFEEoRSeG6T+ltJjpooaWqunzaVv59+dgGbDR7xEAghjIQrgcRi3gYuNH6m8lzVZLu1Dxmid9Tl5CWZ5rPWD46gZveGxPWvblc25aQXMZWFpE24HPH1aNVKftzVI4eWlddeUl43JLCo29gQyyanenOHvZvYG8W4i/QkVrGSOvXPfTT0s3YZW5wbEZeNDuxnbNib680XaeP2o8m92zwNB11NsJXJNzb43zPDT8wdmB/ds8nTynkloL8Pe7uca8r6OWcN2uctz1v0mgQI/qeJyFxYz+KRWSpvc+NNd7opLxZvO3auprneZHweJSGHmIEg5AHD5cWp5C6USzjkCVp4IoUmVgrDSx7r2utbdW9I5KFYRoJ8FMAGdBBm7op+48iOfeSJPAhwDhNUtePXbb+jv0yinjfyE1/nOE2hbMHHuZbcbqz0tlWZYGl359/JIvfWrK4WLf7kSfu9EPK/yNHOyxHY1BZ1X37NSukVXeMqd6Yz7V27Tvvs+GV3igrYpx+i1nRThK5pZo2y79eo/6CuJB+vbyPMDvJ/eY+wVi2lvl4WetqDAJPocAltrLVL2mC6V6S7X8+zRn/H556vn2HJQAA&quot;"/>
+    <we:property name="bookmark" value="&quot;H4sIAAAAAAAAA+0a204bOfRXqnnhJaC5eS59a6GVVr0sW2hXqwohj30c3J3MZD0OkKL8+x7bM5SEQEiaBHYL4sFjH5/71XDlcdkMSzr+SAfgvfQ+UMUor9WLwOt5ldsDEYooICwmecx4EYdCcDyth1rWVeO9vPI0VX3QX2QzoqVBhJtfT3oeLctD2jdfgpYN9LwhqKauaCm/gwPGI61GMOl5cDksa0UNyiNNNRi05wiO38hCsBchRcq0PIcjYNrtRr5gORASERGzTARJkcUI1jgAy9lcEIPakt+vK01lhWTMHiR+zrKMBjFLIj8gBBg3+42s+mXL8I+7x+OhUQ61tF6PtEaWUCnFN6Ru0E0mKJWgEWUCRBEUhOAiibhvUAhZ6pZqMX5zOVSoMFSjQ7mP4vdrJRmSs4pR0Dg9XHn7dTka2NWbqf2jeqQYfAJhjyot9RgxcTk4ZfWo0mp8qqBvYA1Xh6pGS1iI9tRun9UX+wqQOErtT05w517Jm1IyUFMyewNARzALTjW1Mg0dLQnuvOb2GKzIV957iWpwuL/QcmTQ7hzgDV5fVDvIFP6cGNac5ZHvbzdsa280lsrm1HJi7cjCKCGcoBUjmoiQhCF7Wna8sftsxttacVYUKStEHJA0Z36ck5xjuG/RigLFP5UVUzAAzDvlLLdwjtunluwvZcel9HLiagWtmq5SOJKqLu2qYwPLT4kXS3f6zwjUGOlaiFl6ezcI4DXZIPslHTZG8aY6ma1DWVXd9wSBVF1rI4TkYMXohK9GZdkqCd2rCEgWUEogpUlEWFhsOWegoDVSmtGn3Q1+LR97gDZcjoh5FEWpH4SQp5yGFChdnCNe8XNaMeDrSPO0hIpTNcvmX9DurdNkfaicLW5ZzYk7vfrStWNhz3ur6oG91vaNRvT5cvQ8x4lvwubPM1DQmq/iUrfq+G1GRUtY2H1YDuZrDKlee83Xue4X+iF5byBPnO/ZO3d4c4Otrj5o+9N7XBqvg5YD2EHk0W4Q7IbJse+/tL/Wy9FTKr4kong3CHeDaBbR04mwBc7rIowQKvKCkyKMeBDTgqRpvjDCjuvhR3SlhzljMypswjc+Oc15d4DrP7rFz7p17xp6cBP6A9BmhM4+5f9HUKKu1+Hd1nVwqyUtJJQIgyR+VxzU67GlcSBVNyyFs7ro+HsgA4NZBj6Xeu/FgYkSFzBoIaTi+741spM5vKGcJ5ghnA4t87Qo4e6b1w7VBs/m0nzL0v8zzb+q7Dz9HoR2WhsMqZJNp8Pu6500cEj9B+A6zNzzPsn+mX5QwvYD/J3Oszfv38959HicE8N5MMv5psraHC2tUtYc0/4qZe016AuAqapWz89/wWz+W3vMGvVur6R2ucuqKiERyQqS55zSQPgpC3xbUu9NGRoudVFf3n60CoO8YFSImAah4LTI8yDc8uCy6qNV76mN7b3FM8LDCvGtvmKGi7cY2KW08bxC+RjK81q7IjjlDneG04rtxFJS3BlQn+qLjT/79Vrkj/+gYaW95znjtlh7nRx3vGa0bxbvYLwFNS73dtLz2JksuYLKcjYLMn+A2/n8tzLP+DsdxeO6j75+TbKtDGmEaS2meUySxGeiiPx08SPu8+DxPHg8Dx7rfRJcpduMbZMYr+kRJbrVtj6o26SNZL96r5mlgvMiL+IojdMEgKdk638KW86H/yM9GEXY/TOMjAe2YI/oZa05xxudaQoiIIshK/IwhajIIFk8hdxp4Ff9PvYqtMvqP6O4Rd1dVevWAd6OqtZW0Qr+oE1peHO5akP++BK7HAlF4ONkGmcx50kBLMkytrodtxCom5ghN/qPGEMJy+SNRx3dfjZzLPVfGzmBHGgusiCNecizkFH+2K53s3td2tKMKr5qdVg/++5RcTK/9atHuhlSBoe0gjktoJ14OfAFLZeZ3677rcnkX1wJmH2uJgAA&quot;"/>
     <we:property name="creatorSessionId" value="&quot;4ac7c4ef-53a9-41d5-a049-226092e5a97b&quot;"/>
     <we:property name="creatorTenantId" value="&quot;fdd38e72-e446-434f-902c-a144248bfd87&quot;"/>
     <we:property name="creatorUserId" value="&quot;10032003E4869BB2&quot;"/>
     <we:property name="datasetId" value="&quot;da808d81-1aee-4848-b78a-82b898a841ae&quot;"/>
     <we:property name="embedUrl" value="&quot;/reportEmbed?reportId=6eb12ee5-988c-4277-84b2-5ad508bed738&amp;config=eyJjbHVzdGVyVXJsIjoiaHR0cHM6Ly9XQUJJLVNQQUlOLUNFTlRSQUwtQS1QUklNQVJZLXJlZGlyZWN0LmFuYWx5c2lzLndpbmRvd3MubmV0IiwiZW1iZWRGZWF0dXJlcyI6eyJ1c2FnZU1ldHJpY3NWTmV4dCI6dHJ1ZX19&amp;disableSensitivityBanner=true&quot;"/>
-    <we:property name="initialStateBookmark" value="&quot;H4sIAAAAAAAAA7VUXW/bIBT9KxXP0WQMGDtvSZunLm3UTn2ZoukarjMmx7YwzpJF+e8DnKlqNy1Spr3Y3HMv535w4Ei06bsaDg+wRTIlS7AKdGtvKJmQZsTmj4/3y9nT/ZeH2XLh4bZzpm16Mj0SB3aD7sX0A9SBwYOf1xMCdb2CTbAqqHuckA5t3zZQmx84BnuXswOeJgT3Xd1aCJTPDhwG2p0P97bPTT8wnxGUMzt8RuVGFBOaVBITiVwzqQvNilBvPwbEyv4YEqhj+tu2cWAanybGlpSnvKwyluiCiTKVlQh4b5pNfS74de+nQxem4nDvynYf5lF+84kD0+nkG8o4KJGmCnOZiVTnucjk9WyQYF5SkVCZcoRSVIVS17NR0FLnFS3yHNOEFZkS7Hq2lJacC1ag5CgYzxVjedhdmdqdR1seFvvOelV4rYxsM72DRqEm8egt9uNJH8kSoR9sPP/FG8dzO1iFT1hFV+OMOwSlnsNDISvbeoWNMOxvFjts3M1dEFPwfm2/31r0libT5LT2yF/bVWD12169YTXa+SH2cWfsLyGmk3el/qcefNE+gjPmVapEpSXQlCcU8+IfhJVmmFUgFWLJFVeVEvlFNrP11/p3riIDyWkGtADUOVZSUH2RC+IQ54NzfkTvKCPrK0K26N+ZsGgH13egcAUNxtPoxrEZHG/yvoNGoz6vbfh/NF6MY/4XqIeQOr5KJCbxJZmyxgsbwltFYlnr8PkJT9sCJDYFAAA=&quot;"/>
+    <we:property name="initialStateBookmark" value="&quot;H4sIAAAAAAAAA+1ZWW/bRhD+KwaBIi+ysbu8RL/5SIAiceLGqYsgMIzl7lBmQZHqculYNfTfO7skE4mWrKOy7DQV9EDuMfPNNzN7DO8dmZajjI/f8yE4h84ZV4LLQu1Rp+fkddvxhw9vz44+vr1+f3T2GpuLkU6LvHQO7x3N1QD0ZVpWPDMSsPHLVc/hWXbOB+Yt4VkJPWcEqixynqV/Qz0Yu7SqYNJz4G6UFYobkReaazBib3E4vqNueuCiRi50egsXIHTTGkuQMYkE6ftu4NJ+FAU4rKwHWGRzh2B7kmYapZvHePz6bqQQ8X1rqZfwMGB9lzNJXEG5YDJEuXo8Mr0niG5QqFTwzLG4FZQ1zHvnpMiqoX16PdN+UVRKwEdIbFeuUz1GSTIdXqMUyCVXzgRJOFcFUmT7PgNX+2dFrm9sz03x9UQBapbOIZ1cYcutJfAER/A0b0yRPCF9QQSJweN9wgWPYLG1jT2fitH7JzTk1DjzoQm9rv4aoxF72bqd9Zw3qhhasE1gllX8VwVqjBM6wNoOfP6tfXhMkjShPWtBUeVaja8VDMyknvPJAiQGazNpOD3nDHhZKZgaiDF/ARmGn1W0Eof1S42nw1yDx8HWRn2SQiYdo+aDkqCOx1bPaaralGBdWlqMK4IYdjG84RrTVaeYxJOJUYzeQveRiRlXm82m+FmDVJT1xw0YaJaqXKa6gfZrh7Nyu2xaK3icweLZ36JsYn5Xky1kxywNC7HNpgmZSpNnX3amwRzJW54LbO0iWS3eHqRQB8VJNawybhb7vYtquGdA7S0CZbxTpvkga7YUu3HYpzrSHI5jT2640mbPiv/EVDELIc4q5ucQ7ebQE7Fr4rDe0XDEn1N7VuPp8ephv77yK5vANEk4oySIaRCHHhGM0v7S/WI3gTh329hhCM4sfC8Axd67z88J5JdLrg72puDcLkD0I6VjE2O7TsRGbZ2CLuOejLwojiPu+cSnoesuTcEndvbvmT7YQ5R8E/8KruSmrt0+fMMykuQljMswjqn0CGFhENHl5+Itr3MbHgCW8l1mqcBz8zTjzhDwPlZfCJAFY9Oo1mWWM9NfSNsN1uR7512KNNSyL3lWGbGvTnGGLL7mr9pD0GRBltgZa5zRNqKlThZI4r4fU4gC8GM/9EAI8qL8ONX6vxsfslJ70RfEiyRexinerwklzJX+Dr2YoPnXaS4UDAEvz1kXLdxi87VV+1P5cS1emjsRz8u2YFOrVEVmn1oYuLVmODGre+2lCvXaEV19B1MKcFpaIvyMj0pDvCkSmabzNM/bd7Ntq6LQxohUgjWjNT6vsqwhyecJp36fUOEHUoRSMLbLaDPZgYYWquzyaVvpzxVjK7BRrxF9ARBIXzCXhySkgc/C5TeThcei7V6itu6yAeS1Lx547XtRbLXymHxQfmnt2FnhZQFjqPVb1HyZG36MMP+dGXlVx56dsyCaS40XiNOmTPxISON00OkQXqFwd5/SfRZ8IuTQ/m2UY6Tkck1B3j5l+9TtCno5GbYkeJsMS8J+BOC5ruQxi7wwEqGl9rEw1nCn4+Ju9nxvKwmu64bCpWESuAAh7wfU31xalPCEhZGMAhInPhMJELFUGrfsHVda2zpjRyQJgiQU3Es4lz4uLQlLyL8USakbx77HfYiSOGFexMjyW8XLKFv8IHebUQrrlAo2rH6vxemTFQvWuggJGvelkEnkuoGIAx6uUjV4rg8tK+xJu/nCMr8Q84xfV2YrFc3HFUbIws8rL297b4tZz/FNZb3S8X/jjHaUS3u4gETXrA1HXKVly2H79jY141D794HbcHPP+ZgObvRKpy1C8T97SJqe/zhy9/mQ+wY57SJ/qjPpHJY2OZPWoMkmZ9Jj0F8BZo6kL68U/yTn4alCvGVrXt4XlS5HXMA5z2GO020NRIJcQrKpV9QewRUnbdbJFcY34P4BSYjKHJ8jAAA=&quot;"/>
     <we:property name="isFiltersActionButtonVisible" value="true"/>
     <we:property name="isVisualContainerHeaderHidden" value="false"/>
-    <we:property name="pageDisplayName" value="&quot;Timeline&quot;"/>
-    <we:property name="pageName" value="&quot;1bdedb09c08536318996&quot;"/>
+    <we:property name="pageDisplayName" value="&quot;Details&quot;"/>
+    <we:property name="pageName" value="&quot;30fc9e5535f4c8f16b84&quot;"/>
     <we:property name="reportEmbeddedTime" value="&quot;2025-01-11T09:49:07.642Z&quot;"/>
     <we:property name="reportName" value="&quot;Event Registry Data&quot;"/>
     <we:property name="reportState" value="&quot;CONNECTED&quot;"/>
-    <we:property name="reportUrl" value="&quot;/groups/me/reports/6eb12ee5-988c-4277-84b2-5ad508bed738/1bdedb09c08536318996?bookmarkGuid=d56cb977-a242-4fc5-851f-775ee70284df&amp;bookmarkUsage=1&amp;ctid=fdd38e72-e446-434f-902c-a144248bfd87&amp;fromEntryPoint=export&amp;pbi_source=storytelling_addin&quot;"/>
+    <we:property name="reportUrl" value="&quot;/groups/me/reports/6eb12ee5-988c-4277-84b2-5ad508bed738/30fc9e5535f4c8f16b84?bookmarkGuid=d56cb977-a242-4fc5-851f-775ee70284df&amp;bookmarkUsage=1&amp;ctid=fdd38e72-e446-434f-902c-a144248bfd87&amp;fromEntryPoint=export&amp;pbi_source=storytelling_addin&quot;"/>
   </we:properties>
   <we:bindings/>
   <we:snapshot xmlns:r="http://schemas.openxmlformats.org/officeDocument/2006/relationships"/>
@@ -3764,15 +3764,6 @@
 </file>
 
 <file path=customXml/item1.xml><?xml version="1.0" encoding="utf-8"?>
-<?mso-contentType ?>
-<FormTemplates xmlns="http://schemas.microsoft.com/sharepoint/v3/contenttype/forms">
-  <Display>DocumentLibraryForm</Display>
-  <Edit>DocumentLibraryForm</Edit>
-  <New>DocumentLibraryForm</New>
-</FormTemplates>
-</file>
-
-<file path=customXml/item2.xml><?xml version="1.0" encoding="utf-8"?>
 <ct:contentTypeSchema xmlns:ct="http://schemas.microsoft.com/office/2006/metadata/contentType" xmlns:ma="http://schemas.microsoft.com/office/2006/metadata/properties/metaAttributes" ct:_="" ma:_="" ma:contentTypeName="Document" ma:contentTypeID="0x010100CD401524DC532D42A0E0ED886331A72B" ma:contentTypeVersion="15" ma:contentTypeDescription="Create a new document." ma:contentTypeScope="" ma:versionID="aba17d7263e5a17e1efe42a3571abb41">
   <xsd:schema xmlns:xsd="http://www.w3.org/2001/XMLSchema" xmlns:xs="http://www.w3.org/2001/XMLSchema" xmlns:p="http://schemas.microsoft.com/office/2006/metadata/properties" xmlns:ns2="f577acbf-5b0b-4b4f-9948-268e97f8d3a4" xmlns:ns3="b1e4d6ee-9f6f-43f8-a618-24f3d84da28f" targetNamespace="http://schemas.microsoft.com/office/2006/metadata/properties" ma:root="true" ma:fieldsID="e4e3c9c8ed1c3d723d02c9f1cb24d19a" ns2:_="" ns3:_="">
     <xsd:import namespace="f577acbf-5b0b-4b4f-9948-268e97f8d3a4"/>
@@ -4028,6 +4019,15 @@
 </ct:contentTypeSchema>
 </file>
 
+<file path=customXml/item2.xml><?xml version="1.0" encoding="utf-8"?>
+<?mso-contentType ?>
+<FormTemplates xmlns="http://schemas.microsoft.com/sharepoint/v3/contenttype/forms">
+  <Display>DocumentLibraryForm</Display>
+  <Edit>DocumentLibraryForm</Edit>
+  <New>DocumentLibraryForm</New>
+</FormTemplates>
+</file>
+
 <file path=customXml/item3.xml><?xml version="1.0" encoding="utf-8"?>
 <p:properties xmlns:p="http://schemas.microsoft.com/office/2006/metadata/properties" xmlns:xsi="http://www.w3.org/2001/XMLSchema-instance" xmlns:pc="http://schemas.microsoft.com/office/infopath/2007/PartnerControls">
   <documentManagement>
@@ -4038,14 +4038,6 @@
 </file>
 
 <file path=customXml/itemProps1.xml><?xml version="1.0" encoding="utf-8"?>
-<ds:datastoreItem xmlns:ds="http://schemas.openxmlformats.org/officeDocument/2006/customXml" ds:itemID="{E21AFCC0-734A-4A90-A597-A1CB34860DCD}">
-  <ds:schemaRefs>
-    <ds:schemaRef ds:uri="http://schemas.microsoft.com/sharepoint/v3/contenttype/forms"/>
-  </ds:schemaRefs>
-</ds:datastoreItem>
-</file>
-
-<file path=customXml/itemProps2.xml><?xml version="1.0" encoding="utf-8"?>
 <ds:datastoreItem xmlns:ds="http://schemas.openxmlformats.org/officeDocument/2006/customXml" ds:itemID="{1DD29C39-1C4E-4B06-A1F4-2510F2DACF6E}">
   <ds:schemaRefs>
     <ds:schemaRef ds:uri="http://schemas.microsoft.com/office/2006/metadata/contentType"/>
@@ -4060,6 +4052,14 @@
     <ds:schemaRef ds:uri="http://purl.org/dc/elements/1.1/"/>
     <ds:schemaRef ds:uri="http://purl.org/dc/terms/"/>
     <ds:schemaRef ds:uri="http://schemas.microsoft.com/internal/obd"/>
+  </ds:schemaRefs>
+</ds:datastoreItem>
+</file>
+
+<file path=customXml/itemProps2.xml><?xml version="1.0" encoding="utf-8"?>
+<ds:datastoreItem xmlns:ds="http://schemas.openxmlformats.org/officeDocument/2006/customXml" ds:itemID="{E21AFCC0-734A-4A90-A597-A1CB34860DCD}">
+  <ds:schemaRefs>
+    <ds:schemaRef ds:uri="http://schemas.microsoft.com/sharepoint/v3/contenttype/forms"/>
   </ds:schemaRefs>
 </ds:datastoreItem>
 </file>

</xml_diff>